<commit_message>
phase3: close final reliability and performance gates
</commit_message>
<xml_diff>
--- a/thesis-deck-system/artifacts/phase2/acceptance-deck.pptx
+++ b/thesis-deck-system/artifacts/phase2/acceptance-deck.pptx
@@ -5487,7 +5487,7 @@
           <a:p>
             <a:r>
               <a:rPr sz="1600"/>
-              <a:t>Metric｜{'name': 'CV', 'value': 24, 'uncertainty': 5, 'units': '%'}</a:t>
+              <a:t>Metric｜mean conductivity increase: 24% ± 5% SD</a:t>
             </a:r>
           </a:p>
         </p:txBody>
@@ -5651,7 +5651,7 @@
           <a:p>
             <a:r>
               <a:rPr sz="1600"/>
-              <a:t>Metric｜{'name': 'CV', 'value': 4, 'uncertainty': 5, 'units': '%'}</a:t>
+              <a:t>Metric｜signal CV decrease: 4% ± 6% SD</a:t>
             </a:r>
           </a:p>
         </p:txBody>
@@ -7110,7 +7110,7 @@
           <a:p>
             <a:r>
               <a:rPr sz="1600"/>
-              <a:t>Metric｜{'name': 'CV', 'value': 24, 'uncertainty': 5, 'units': '%'}</a:t>
+              <a:t>Metric｜signal CV decrease: 38% ± 7% SD</a:t>
             </a:r>
           </a:p>
         </p:txBody>

</xml_diff>